<commit_message>
feat(autonomous): deliver phases 8–11 with governance, maintenance, and Jira publish
Add NL-goal autonomous login/checkout, replan and verification, CI-safe suite
governance, maintenance agent with locator proposals, live Jira ticket creation,
nightly workflow, tests, docs, and refreshed technical presentation deck.

Co-authored-by: Cursor <cursoragent@cursor.com>
</commit_message>
<xml_diff>
--- a/docs/Agentic-Healing-Technical-Presentation.pptx
+++ b/docs/Agentic-Healing-Technical-Presentation.pptx
@@ -26,9 +26,12 @@
     <p:sldId id="274" r:id="rId20"/>
     <p:sldId id="275" r:id="rId21"/>
     <p:sldId id="276" r:id="rId22"/>
+    <p:sldId id="277" r:id="rId23"/>
+    <p:sldId id="278" r:id="rId24"/>
+    <p:sldId id="279" r:id="rId25"/>
   </p:sldIdLst>
   <p:notesMasterIdLst>
-    <p:notesMasterId r:id="rId23"/>
+    <p:notesMasterId r:id="rId26"/>
   </p:notesMasterIdLst>
   <p:sldSz cx="12192000" cy="6858000"/>
   <p:notesSz cx="6858000" cy="12192000"/>
@@ -1690,6 +1693,270 @@
             <a:fld id="{F7021451-1387-4CA6-816F-3879F97B5CBC}" type="slidenum">
               <a:rPr lang="en-US"/>
               <a:t>21</a:t>
+            </a:fld>
+            <a:endParaRPr lang="en-US"/>
+          </a:p>
+        </p:txBody>
+      </p:sp>
+    </p:spTree>
+    <p:extLst>
+      <p:ext uri="{BB962C8B-B14F-4D97-AF65-F5344CB8AC3E}">
+        <p14:creationId xmlns:p14="http://schemas.microsoft.com/office/powerpoint/2010/main" val="1024086991"/>
+      </p:ext>
+    </p:extLst>
+  </p:cSld>
+  <p:clrMapOvr>
+    <a:masterClrMapping/>
+  </p:clrMapOvr>
+</p:notes>
+</file>
+
+<file path=ppt/notesSlides/notesSlide22.xml><?xml version="1.0" encoding="utf-8"?>
+<p:notes xmlns:a="http://schemas.openxmlformats.org/drawingml/2006/main" xmlns:r="http://schemas.openxmlformats.org/officeDocument/2006/relationships" xmlns:p="http://schemas.openxmlformats.org/presentationml/2006/main">
+  <p:cSld>
+    <p:spTree>
+      <p:nvGrpSpPr>
+        <p:cNvPr id="1" name=""/>
+        <p:cNvGrpSpPr/>
+        <p:nvPr/>
+      </p:nvGrpSpPr>
+      <p:grpSpPr>
+        <a:xfrm>
+          <a:off x="0" y="0"/>
+          <a:ext cx="0" cy="0"/>
+          <a:chOff x="0" y="0"/>
+          <a:chExt cx="0" cy="0"/>
+        </a:xfrm>
+      </p:grpSpPr>
+      <p:sp>
+        <p:nvSpPr>
+          <p:cNvPr id="2" name="Slide Image Placeholder 1"/>
+          <p:cNvSpPr>
+            <a:spLocks noGrp="1" noRot="1" noChangeAspect="1"/>
+          </p:cNvSpPr>
+          <p:nvPr>
+            <p:ph type="sldImg"/>
+          </p:nvPr>
+        </p:nvSpPr>
+        <p:spPr/>
+      </p:sp>
+      <p:sp>
+        <p:nvSpPr>
+          <p:cNvPr id="3" name="Notes Placeholder 2"/>
+          <p:cNvSpPr>
+            <a:spLocks noGrp="1"/>
+          </p:cNvSpPr>
+          <p:nvPr>
+            <p:ph type="body" idx="1"/>
+          </p:nvPr>
+        </p:nvSpPr>
+        <p:spPr/>
+        <p:txBody>
+          <a:bodyPr/>
+          <a:lstStyle/>
+          <a:p>
+            <a:r>
+              <a:rPr lang="en-US" dirty="0"/>
+              <a:t/>
+            </a:r>
+            <a:endParaRPr lang="en-US" dirty="0"/>
+          </a:p>
+        </p:txBody>
+      </p:sp>
+      <p:sp>
+        <p:nvSpPr>
+          <p:cNvPr id="4" name="Slide Number Placeholder 3"/>
+          <p:cNvSpPr>
+            <a:spLocks noGrp="1"/>
+          </p:cNvSpPr>
+          <p:nvPr>
+            <p:ph type="sldNum" sz="quarter" idx="10"/>
+          </p:nvPr>
+        </p:nvSpPr>
+        <p:spPr/>
+        <p:txBody>
+          <a:bodyPr/>
+          <a:lstStyle/>
+          <a:p>
+            <a:fld id="{F7021451-1387-4CA6-816F-3879F97B5CBC}" type="slidenum">
+              <a:rPr lang="en-US"/>
+              <a:t>22</a:t>
+            </a:fld>
+            <a:endParaRPr lang="en-US"/>
+          </a:p>
+        </p:txBody>
+      </p:sp>
+    </p:spTree>
+    <p:extLst>
+      <p:ext uri="{BB962C8B-B14F-4D97-AF65-F5344CB8AC3E}">
+        <p14:creationId xmlns:p14="http://schemas.microsoft.com/office/powerpoint/2010/main" val="1024086991"/>
+      </p:ext>
+    </p:extLst>
+  </p:cSld>
+  <p:clrMapOvr>
+    <a:masterClrMapping/>
+  </p:clrMapOvr>
+</p:notes>
+</file>
+
+<file path=ppt/notesSlides/notesSlide23.xml><?xml version="1.0" encoding="utf-8"?>
+<p:notes xmlns:a="http://schemas.openxmlformats.org/drawingml/2006/main" xmlns:r="http://schemas.openxmlformats.org/officeDocument/2006/relationships" xmlns:p="http://schemas.openxmlformats.org/presentationml/2006/main">
+  <p:cSld>
+    <p:spTree>
+      <p:nvGrpSpPr>
+        <p:cNvPr id="1" name=""/>
+        <p:cNvGrpSpPr/>
+        <p:nvPr/>
+      </p:nvGrpSpPr>
+      <p:grpSpPr>
+        <a:xfrm>
+          <a:off x="0" y="0"/>
+          <a:ext cx="0" cy="0"/>
+          <a:chOff x="0" y="0"/>
+          <a:chExt cx="0" cy="0"/>
+        </a:xfrm>
+      </p:grpSpPr>
+      <p:sp>
+        <p:nvSpPr>
+          <p:cNvPr id="2" name="Slide Image Placeholder 1"/>
+          <p:cNvSpPr>
+            <a:spLocks noGrp="1" noRot="1" noChangeAspect="1"/>
+          </p:cNvSpPr>
+          <p:nvPr>
+            <p:ph type="sldImg"/>
+          </p:nvPr>
+        </p:nvSpPr>
+        <p:spPr/>
+      </p:sp>
+      <p:sp>
+        <p:nvSpPr>
+          <p:cNvPr id="3" name="Notes Placeholder 2"/>
+          <p:cNvSpPr>
+            <a:spLocks noGrp="1"/>
+          </p:cNvSpPr>
+          <p:nvPr>
+            <p:ph type="body" idx="1"/>
+          </p:nvPr>
+        </p:nvSpPr>
+        <p:spPr/>
+        <p:txBody>
+          <a:bodyPr/>
+          <a:lstStyle/>
+          <a:p>
+            <a:r>
+              <a:rPr lang="en-US" dirty="0"/>
+              <a:t/>
+            </a:r>
+            <a:endParaRPr lang="en-US" dirty="0"/>
+          </a:p>
+        </p:txBody>
+      </p:sp>
+      <p:sp>
+        <p:nvSpPr>
+          <p:cNvPr id="4" name="Slide Number Placeholder 3"/>
+          <p:cNvSpPr>
+            <a:spLocks noGrp="1"/>
+          </p:cNvSpPr>
+          <p:nvPr>
+            <p:ph type="sldNum" sz="quarter" idx="10"/>
+          </p:nvPr>
+        </p:nvSpPr>
+        <p:spPr/>
+        <p:txBody>
+          <a:bodyPr/>
+          <a:lstStyle/>
+          <a:p>
+            <a:fld id="{F7021451-1387-4CA6-816F-3879F97B5CBC}" type="slidenum">
+              <a:rPr lang="en-US"/>
+              <a:t>23</a:t>
+            </a:fld>
+            <a:endParaRPr lang="en-US"/>
+          </a:p>
+        </p:txBody>
+      </p:sp>
+    </p:spTree>
+    <p:extLst>
+      <p:ext uri="{BB962C8B-B14F-4D97-AF65-F5344CB8AC3E}">
+        <p14:creationId xmlns:p14="http://schemas.microsoft.com/office/powerpoint/2010/main" val="1024086991"/>
+      </p:ext>
+    </p:extLst>
+  </p:cSld>
+  <p:clrMapOvr>
+    <a:masterClrMapping/>
+  </p:clrMapOvr>
+</p:notes>
+</file>
+
+<file path=ppt/notesSlides/notesSlide24.xml><?xml version="1.0" encoding="utf-8"?>
+<p:notes xmlns:a="http://schemas.openxmlformats.org/drawingml/2006/main" xmlns:r="http://schemas.openxmlformats.org/officeDocument/2006/relationships" xmlns:p="http://schemas.openxmlformats.org/presentationml/2006/main">
+  <p:cSld>
+    <p:spTree>
+      <p:nvGrpSpPr>
+        <p:cNvPr id="1" name=""/>
+        <p:cNvGrpSpPr/>
+        <p:nvPr/>
+      </p:nvGrpSpPr>
+      <p:grpSpPr>
+        <a:xfrm>
+          <a:off x="0" y="0"/>
+          <a:ext cx="0" cy="0"/>
+          <a:chOff x="0" y="0"/>
+          <a:chExt cx="0" cy="0"/>
+        </a:xfrm>
+      </p:grpSpPr>
+      <p:sp>
+        <p:nvSpPr>
+          <p:cNvPr id="2" name="Slide Image Placeholder 1"/>
+          <p:cNvSpPr>
+            <a:spLocks noGrp="1" noRot="1" noChangeAspect="1"/>
+          </p:cNvSpPr>
+          <p:nvPr>
+            <p:ph type="sldImg"/>
+          </p:nvPr>
+        </p:nvSpPr>
+        <p:spPr/>
+      </p:sp>
+      <p:sp>
+        <p:nvSpPr>
+          <p:cNvPr id="3" name="Notes Placeholder 2"/>
+          <p:cNvSpPr>
+            <a:spLocks noGrp="1"/>
+          </p:cNvSpPr>
+          <p:nvPr>
+            <p:ph type="body" idx="1"/>
+          </p:nvPr>
+        </p:nvSpPr>
+        <p:spPr/>
+        <p:txBody>
+          <a:bodyPr/>
+          <a:lstStyle/>
+          <a:p>
+            <a:r>
+              <a:rPr lang="en-US" dirty="0"/>
+              <a:t/>
+            </a:r>
+            <a:endParaRPr lang="en-US" dirty="0"/>
+          </a:p>
+        </p:txBody>
+      </p:sp>
+      <p:sp>
+        <p:nvSpPr>
+          <p:cNvPr id="4" name="Slide Number Placeholder 3"/>
+          <p:cNvSpPr>
+            <a:spLocks noGrp="1"/>
+          </p:cNvSpPr>
+          <p:nvPr>
+            <p:ph type="sldNum" sz="quarter" idx="10"/>
+          </p:nvPr>
+        </p:nvSpPr>
+        <p:spPr/>
+        <p:txBody>
+          <a:bodyPr/>
+          <a:lstStyle/>
+          <a:p>
+            <a:fld id="{F7021451-1387-4CA6-816F-3879F97B5CBC}" type="slidenum">
+              <a:rPr lang="en-US"/>
+              <a:t>24</a:t>
             </a:fld>
             <a:endParaRPr lang="en-US"/>
           </a:p>
@@ -2727,7 +2994,7 @@
                 <a:ea typeface="Arial" pitchFamily="34" charset="-122"/>
                 <a:cs typeface="Arial" pitchFamily="34" charset="-120"/>
               </a:rPr>
-              <a:t>Architecture • Agent loop • LLM integration • Plug-and-play SDK • How to use</a:t>
+              <a:t>Architecture • Agent loop • Autonomous QA (Phases 8–11) • Plug-and-play SDK</a:t>
             </a:r>
             <a:endParaRPr lang="en-US" sz="1500" dirty="0"/>
           </a:p>
@@ -7410,6 +7677,27 @@
             </a:r>
             <a:endParaRPr lang="en-US" sz="1300" dirty="0"/>
           </a:p>
+          <a:p>
+            <a:pPr marL="342900" indent="-342900">
+              <a:lnSpc>
+                <a:spcPct val="116000"/>
+              </a:lnSpc>
+              <a:buSzPct val="100000"/>
+              <a:buChar char="•"/>
+            </a:pPr>
+            <a:r>
+              <a:rPr lang="en-US" sz="1300" dirty="0">
+                <a:solidFill>
+                  <a:srgbClr val="2D3748"/>
+                </a:solidFill>
+                <a:latin typeface="Arial" pitchFamily="34" charset="0"/>
+                <a:ea typeface="Arial" pitchFamily="34" charset="-122"/>
+                <a:cs typeface="Arial" pitchFamily="34" charset="-120"/>
+              </a:rPr>
+              <a:t>Phases 8–11: fully autonomous QA (delivered)</a:t>
+            </a:r>
+            <a:endParaRPr lang="en-US" sz="1300" dirty="0"/>
+          </a:p>
         </p:txBody>
       </p:sp>
     </p:spTree>
@@ -7495,7 +7783,7 @@
                 <a:ea typeface="Arial" pitchFamily="34" charset="-122"/>
                 <a:cs typeface="Arial" pitchFamily="34" charset="-120"/>
               </a:rPr>
-              <a:t>Roadmap</a:t>
+              <a:t>Roadmap — Delivered (Phases 8–11)</a:t>
             </a:r>
             <a:endParaRPr lang="en-US" sz="2100" dirty="0"/>
           </a:p>
@@ -7538,7 +7826,7 @@
                 <a:ea typeface="Arial" pitchFamily="34" charset="-122"/>
                 <a:cs typeface="Arial" pitchFamily="34" charset="-120"/>
               </a:rPr>
-              <a:t>Vision agent — screenshot analysis for canvas/shadow DOM cases.</a:t>
+              <a:t>Phase 8 — Autonomous login MVP: runAutonomousTest() from NL goal, zero locators in spec.</a:t>
             </a:r>
             <a:endParaRPr lang="en-US" sz="1300" dirty="0"/>
           </a:p>
@@ -7559,7 +7847,7 @@
                 <a:ea typeface="Arial" pitchFamily="34" charset="-122"/>
                 <a:cs typeface="Arial" pitchFamily="34" charset="-120"/>
               </a:rPr>
-              <a:t>Hosted healing-service SaaS option for enterprise adopters.</a:t>
+              <a:t>Phase 9 — Multi-step checkout: verification agent, replan on assertion failure, 10-journey eval set.</a:t>
             </a:r>
             <a:endParaRPr lang="en-US" sz="1300" dirty="0"/>
           </a:p>
@@ -7580,7 +7868,7 @@
                 <a:ea typeface="Arial" pitchFamily="34" charset="-122"/>
                 <a:cs typeface="Arial" pitchFamily="34" charset="-120"/>
               </a:rPr>
-              <a:t>npm publish ai-healing-sdk@2.x with migration guide.</a:t>
+              <a:t>Phase 10 — Production governance: env secrets, domain allowlist, cost caps, suite KPIs, CI smoke.</a:t>
             </a:r>
             <a:endParaRPr lang="en-US" sz="1300" dirty="0"/>
           </a:p>
@@ -7601,7 +7889,7 @@
                 <a:ea typeface="Arial" pitchFamily="34" charset="-122"/>
                 <a:cs typeface="Arial" pitchFamily="34" charset="-120"/>
               </a:rPr>
-              <a:t>Evaluation harness: held-out failure DOM set for heal-rate KPIs.</a:t>
+              <a:t>Phase 11 — Maintenance agent: locator persistence proposals (PR review), Jira tickets on repeated failure.</a:t>
             </a:r>
             <a:endParaRPr lang="en-US" sz="1300" dirty="0"/>
           </a:p>
@@ -7622,28 +7910,7 @@
                 <a:ea typeface="Arial" pitchFamily="34" charset="-122"/>
                 <a:cs typeface="Arial" pitchFamily="34" charset="-120"/>
               </a:rPr>
-              <a:t>Human review queue for LLM-persisted locators (optional PR bot).</a:t>
-            </a:r>
-            <a:endParaRPr lang="en-US" sz="1300" dirty="0"/>
-          </a:p>
-          <a:p>
-            <a:pPr marL="342900" indent="-342900">
-              <a:lnSpc>
-                <a:spcPct val="116000"/>
-              </a:lnSpc>
-              <a:buSzPct val="100000"/>
-              <a:buChar char="•"/>
-            </a:pPr>
-            <a:r>
-              <a:rPr lang="en-US" sz="1300" dirty="0">
-                <a:solidFill>
-                  <a:srgbClr val="2D3748"/>
-                </a:solidFill>
-                <a:latin typeface="Arial" pitchFamily="34" charset="0"/>
-                <a:ea typeface="Arial" pitchFamily="34" charset="-122"/>
-                <a:cs typeface="Arial" pitchFamily="34" charset="-120"/>
-              </a:rPr>
-              <a:t>Dashboard widgets: agent heal rate, LLM cost per suite.</a:t>
+              <a:t>Fully autonomous QA loop: heal → run → verify → govern → maintain.</a:t>
             </a:r>
             <a:endParaRPr lang="en-US" sz="1300" dirty="0"/>
           </a:p>
@@ -7707,7 +7974,7 @@
                 <a:ea typeface="Arial" pitchFamily="34" charset="-122"/>
                 <a:cs typeface="Arial" pitchFamily="34" charset="-120"/>
               </a:rPr>
-              <a:t>PRD: docs/PRD-Agentic-AI-Conversion.md</a:t>
+              <a:t>Commands: npm run test:autonomous • test:autonomous-ci-smoke</a:t>
             </a:r>
             <a:endParaRPr lang="en-US" sz="1000" dirty="0"/>
           </a:p>
@@ -7724,6 +7991,1712 @@
 <file path=ppt/slides/slide21.xml><?xml version="1.0" encoding="utf-8"?>
 <p:sld xmlns:a="http://schemas.openxmlformats.org/drawingml/2006/main" xmlns:r="http://schemas.openxmlformats.org/officeDocument/2006/relationships" xmlns:p="http://schemas.openxmlformats.org/presentationml/2006/main">
   <p:cSld name="Slide 21">
+    <p:spTree>
+      <p:nvGrpSpPr>
+        <p:cNvPr id="1" name=""/>
+        <p:cNvGrpSpPr/>
+        <p:nvPr/>
+      </p:nvGrpSpPr>
+      <p:grpSpPr>
+        <a:xfrm>
+          <a:off x="0" y="0"/>
+          <a:ext cx="0" cy="0"/>
+          <a:chOff x="0" y="0"/>
+          <a:chExt cx="0" cy="0"/>
+        </a:xfrm>
+      </p:grpSpPr>
+      <p:sp>
+        <p:nvSpPr>
+          <p:cNvPr id="2" name="Shape 0"/>
+          <p:cNvSpPr/>
+          <p:nvPr/>
+        </p:nvSpPr>
+        <p:spPr>
+          <a:xfrm>
+            <a:off x="0" y="0"/>
+            <a:ext cx="12188952" cy="256032"/>
+          </a:xfrm>
+          <a:prstGeom prst="rect">
+            <a:avLst/>
+          </a:prstGeom>
+          <a:solidFill>
+            <a:srgbClr val="2F6FB0"/>
+          </a:solidFill>
+          <a:ln w="12700">
+            <a:solidFill>
+              <a:srgbClr val="333333"/>
+            </a:solidFill>
+            <a:prstDash val="solid"/>
+          </a:ln>
+        </p:spPr>
+      </p:sp>
+      <p:sp>
+        <p:nvSpPr>
+          <p:cNvPr id="3" name="Text 1"/>
+          <p:cNvSpPr/>
+          <p:nvPr/>
+        </p:nvSpPr>
+        <p:spPr>
+          <a:xfrm>
+            <a:off x="548640" y="411480"/>
+            <a:ext cx="10972800" cy="548640"/>
+          </a:xfrm>
+          <a:prstGeom prst="rect">
+            <a:avLst/>
+          </a:prstGeom>
+          <a:noFill/>
+          <a:ln/>
+        </p:spPr>
+        <p:txBody>
+          <a:bodyPr wrap="square" rtlCol="0" anchor="ctr"/>
+          <a:lstStyle/>
+          <a:p>
+            <a:pPr indent="0" marL="0">
+              <a:buNone/>
+            </a:pPr>
+            <a:r>
+              <a:rPr lang="en-US" sz="2100" b="1" dirty="0">
+                <a:solidFill>
+                  <a:srgbClr val="1B365D"/>
+                </a:solidFill>
+                <a:latin typeface="Arial" pitchFamily="34" charset="0"/>
+                <a:ea typeface="Arial" pitchFamily="34" charset="-122"/>
+                <a:cs typeface="Arial" pitchFamily="34" charset="-120"/>
+              </a:rPr>
+              <a:t>Autonomous Phases at a Glance</a:t>
+            </a:r>
+            <a:endParaRPr lang="en-US" sz="2100" dirty="0"/>
+          </a:p>
+        </p:txBody>
+      </p:sp>
+      <p:graphicFrame>
+        <p:nvGraphicFramePr>
+          <p:cNvPr id="22" name="Table 0"/>
+          <p:cNvGraphicFramePr>
+            <a:graphicFrameLocks noGrp="1"/>
+          </p:cNvGraphicFramePr>
+          <p:nvPr>
+            <p:extLst>
+              <p:ext uri="{D42A27DB-BD31-4B8C-83A1-F6EECF244321}">
+                <p14:modId xmlns:p14="http://schemas.microsoft.com/office/powerpoint/2010/main" val="1579011935"/>
+              </p:ext>
+            </p:extLst>
+          </p:nvPr>
+        </p:nvGraphicFramePr>
+        <p:xfrm>
+          <a:off x="548640" y="1051560"/>
+          <a:ext cx="11064240" cy="914400"/>
+        </p:xfrm>
+        <a:graphic>
+          <a:graphicData uri="http://schemas.openxmlformats.org/drawingml/2006/table">
+            <a:tbl>
+              <a:tblPr/>
+              <a:tblGrid>
+                <a:gridCol w="2560320"/>
+                <a:gridCol w="4206240"/>
+                <a:gridCol w="4297680"/>
+              </a:tblGrid>
+              <a:tr h="0">
+                <a:tc>
+                  <a:txBody>
+                    <a:bodyPr/>
+                    <a:lstStyle/>
+                    <a:p>
+                      <a:pPr indent="0" marL="0">
+                        <a:buNone/>
+                      </a:pPr>
+                      <a:r>
+                        <a:rPr lang="en-US" sz="1100" b="1" dirty="0">
+                          <a:solidFill>
+                            <a:srgbClr val="FFFFFF"/>
+                          </a:solidFill>
+                          <a:latin typeface="Arial" pitchFamily="34" charset="0"/>
+                          <a:ea typeface="Arial" pitchFamily="34" charset="-122"/>
+                          <a:cs typeface="Arial" pitchFamily="34" charset="-120"/>
+                        </a:rPr>
+                        <a:t>Phase</a:t>
+                      </a:r>
+                      <a:endParaRPr lang="en-US" sz="1100" dirty="0">
+                        <a:latin typeface="Arial" charset="0"/>
+                        <a:ea typeface="Arial" charset="0"/>
+                        <a:cs typeface="Arial" charset="0"/>
+                      </a:endParaRPr>
+                    </a:p>
+                  </a:txBody>
+                  <a:tcPr marL="91440" marR="91440" marT="45720" marB="45720">
+                    <a:lnL w="12700" cap="flat" cmpd="sng" algn="ctr">
+                      <a:solidFill>
+                        <a:srgbClr val="D9E2EC"/>
+                      </a:solidFill>
+                      <a:prstDash val="solid"/>
+                      <a:round/>
+                      <a:headEnd type="none" w="med" len="med"/>
+                      <a:tailEnd type="none" w="med" len="med"/>
+                    </a:lnL>
+                    <a:lnR w="12700" cap="flat" cmpd="sng" algn="ctr">
+                      <a:solidFill>
+                        <a:srgbClr val="D9E2EC"/>
+                      </a:solidFill>
+                      <a:prstDash val="solid"/>
+                      <a:round/>
+                      <a:headEnd type="none" w="med" len="med"/>
+                      <a:tailEnd type="none" w="med" len="med"/>
+                    </a:lnR>
+                    <a:lnT w="12700" cap="flat" cmpd="sng" algn="ctr">
+                      <a:solidFill>
+                        <a:srgbClr val="D9E2EC"/>
+                      </a:solidFill>
+                      <a:prstDash val="solid"/>
+                      <a:round/>
+                      <a:headEnd type="none" w="med" len="med"/>
+                      <a:tailEnd type="none" w="med" len="med"/>
+                    </a:lnT>
+                    <a:lnB w="12700" cap="flat" cmpd="sng" algn="ctr">
+                      <a:solidFill>
+                        <a:srgbClr val="D9E2EC"/>
+                      </a:solidFill>
+                      <a:prstDash val="solid"/>
+                      <a:round/>
+                      <a:headEnd type="none" w="med" len="med"/>
+                      <a:tailEnd type="none" w="med" len="med"/>
+                    </a:lnB>
+                    <a:solidFill>
+                      <a:srgbClr val="1B365D"/>
+                    </a:solidFill>
+                  </a:tcPr>
+                </a:tc>
+                <a:tc>
+                  <a:txBody>
+                    <a:bodyPr/>
+                    <a:lstStyle/>
+                    <a:p>
+                      <a:pPr indent="0" marL="0">
+                        <a:buNone/>
+                      </a:pPr>
+                      <a:r>
+                        <a:rPr lang="en-US" sz="1100" b="1" dirty="0">
+                          <a:solidFill>
+                            <a:srgbClr val="FFFFFF"/>
+                          </a:solidFill>
+                          <a:latin typeface="Arial" pitchFamily="34" charset="0"/>
+                          <a:ea typeface="Arial" pitchFamily="34" charset="-122"/>
+                          <a:cs typeface="Arial" pitchFamily="34" charset="-120"/>
+                        </a:rPr>
+                        <a:t>Capability</a:t>
+                      </a:r>
+                      <a:endParaRPr lang="en-US" sz="1100" dirty="0">
+                        <a:latin typeface="Arial" charset="0"/>
+                        <a:ea typeface="Arial" charset="0"/>
+                        <a:cs typeface="Arial" charset="0"/>
+                      </a:endParaRPr>
+                    </a:p>
+                  </a:txBody>
+                  <a:tcPr marL="91440" marR="91440" marT="45720" marB="45720">
+                    <a:lnL w="12700" cap="flat" cmpd="sng" algn="ctr">
+                      <a:solidFill>
+                        <a:srgbClr val="D9E2EC"/>
+                      </a:solidFill>
+                      <a:prstDash val="solid"/>
+                      <a:round/>
+                      <a:headEnd type="none" w="med" len="med"/>
+                      <a:tailEnd type="none" w="med" len="med"/>
+                    </a:lnL>
+                    <a:lnR w="12700" cap="flat" cmpd="sng" algn="ctr">
+                      <a:solidFill>
+                        <a:srgbClr val="D9E2EC"/>
+                      </a:solidFill>
+                      <a:prstDash val="solid"/>
+                      <a:round/>
+                      <a:headEnd type="none" w="med" len="med"/>
+                      <a:tailEnd type="none" w="med" len="med"/>
+                    </a:lnR>
+                    <a:lnT w="12700" cap="flat" cmpd="sng" algn="ctr">
+                      <a:solidFill>
+                        <a:srgbClr val="D9E2EC"/>
+                      </a:solidFill>
+                      <a:prstDash val="solid"/>
+                      <a:round/>
+                      <a:headEnd type="none" w="med" len="med"/>
+                      <a:tailEnd type="none" w="med" len="med"/>
+                    </a:lnT>
+                    <a:lnB w="12700" cap="flat" cmpd="sng" algn="ctr">
+                      <a:solidFill>
+                        <a:srgbClr val="D9E2EC"/>
+                      </a:solidFill>
+                      <a:prstDash val="solid"/>
+                      <a:round/>
+                      <a:headEnd type="none" w="med" len="med"/>
+                      <a:tailEnd type="none" w="med" len="med"/>
+                    </a:lnB>
+                    <a:solidFill>
+                      <a:srgbClr val="1B365D"/>
+                    </a:solidFill>
+                  </a:tcPr>
+                </a:tc>
+                <a:tc>
+                  <a:txBody>
+                    <a:bodyPr/>
+                    <a:lstStyle/>
+                    <a:p>
+                      <a:pPr indent="0" marL="0">
+                        <a:buNone/>
+                      </a:pPr>
+                      <a:r>
+                        <a:rPr lang="en-US" sz="1100" b="1" dirty="0">
+                          <a:solidFill>
+                            <a:srgbClr val="FFFFFF"/>
+                          </a:solidFill>
+                          <a:latin typeface="Arial" pitchFamily="34" charset="0"/>
+                          <a:ea typeface="Arial" pitchFamily="34" charset="-122"/>
+                          <a:cs typeface="Arial" pitchFamily="34" charset="-120"/>
+                        </a:rPr>
+                        <a:t>Key API / Command</a:t>
+                      </a:r>
+                      <a:endParaRPr lang="en-US" sz="1100" dirty="0">
+                        <a:latin typeface="Arial" charset="0"/>
+                        <a:ea typeface="Arial" charset="0"/>
+                        <a:cs typeface="Arial" charset="0"/>
+                      </a:endParaRPr>
+                    </a:p>
+                  </a:txBody>
+                  <a:tcPr marL="91440" marR="91440" marT="45720" marB="45720">
+                    <a:lnL w="12700" cap="flat" cmpd="sng" algn="ctr">
+                      <a:solidFill>
+                        <a:srgbClr val="D9E2EC"/>
+                      </a:solidFill>
+                      <a:prstDash val="solid"/>
+                      <a:round/>
+                      <a:headEnd type="none" w="med" len="med"/>
+                      <a:tailEnd type="none" w="med" len="med"/>
+                    </a:lnL>
+                    <a:lnR w="12700" cap="flat" cmpd="sng" algn="ctr">
+                      <a:solidFill>
+                        <a:srgbClr val="D9E2EC"/>
+                      </a:solidFill>
+                      <a:prstDash val="solid"/>
+                      <a:round/>
+                      <a:headEnd type="none" w="med" len="med"/>
+                      <a:tailEnd type="none" w="med" len="med"/>
+                    </a:lnR>
+                    <a:lnT w="12700" cap="flat" cmpd="sng" algn="ctr">
+                      <a:solidFill>
+                        <a:srgbClr val="D9E2EC"/>
+                      </a:solidFill>
+                      <a:prstDash val="solid"/>
+                      <a:round/>
+                      <a:headEnd type="none" w="med" len="med"/>
+                      <a:tailEnd type="none" w="med" len="med"/>
+                    </a:lnT>
+                    <a:lnB w="12700" cap="flat" cmpd="sng" algn="ctr">
+                      <a:solidFill>
+                        <a:srgbClr val="D9E2EC"/>
+                      </a:solidFill>
+                      <a:prstDash val="solid"/>
+                      <a:round/>
+                      <a:headEnd type="none" w="med" len="med"/>
+                      <a:tailEnd type="none" w="med" len="med"/>
+                    </a:lnB>
+                    <a:solidFill>
+                      <a:srgbClr val="1B365D"/>
+                    </a:solidFill>
+                  </a:tcPr>
+                </a:tc>
+              </a:tr>
+              <a:tr h="0">
+                <a:tc>
+                  <a:txBody>
+                    <a:bodyPr/>
+                    <a:lstStyle/>
+                    <a:p>
+                      <a:pPr indent="0" marL="0">
+                        <a:buNone/>
+                      </a:pPr>
+                      <a:r>
+                        <a:rPr lang="en-US" sz="1100" dirty="0">
+                          <a:solidFill>
+                            <a:srgbClr val="2D3748"/>
+                          </a:solidFill>
+                          <a:latin typeface="Arial" pitchFamily="34" charset="0"/>
+                          <a:ea typeface="Arial" pitchFamily="34" charset="-122"/>
+                          <a:cs typeface="Arial" pitchFamily="34" charset="-120"/>
+                        </a:rPr>
+                        <a:t>8 — Login MVP</a:t>
+                      </a:r>
+                      <a:endParaRPr lang="en-US" sz="1100" dirty="0">
+                        <a:latin typeface="Arial" charset="0"/>
+                        <a:ea typeface="Arial" charset="0"/>
+                        <a:cs typeface="Arial" charset="0"/>
+                      </a:endParaRPr>
+                    </a:p>
+                  </a:txBody>
+                  <a:tcPr marL="91440" marR="91440" marT="45720" marB="45720">
+                    <a:lnL w="12700" cap="flat" cmpd="sng" algn="ctr">
+                      <a:solidFill>
+                        <a:srgbClr val="D9E2EC"/>
+                      </a:solidFill>
+                      <a:prstDash val="solid"/>
+                      <a:round/>
+                      <a:headEnd type="none" w="med" len="med"/>
+                      <a:tailEnd type="none" w="med" len="med"/>
+                    </a:lnL>
+                    <a:lnR w="12700" cap="flat" cmpd="sng" algn="ctr">
+                      <a:solidFill>
+                        <a:srgbClr val="D9E2EC"/>
+                      </a:solidFill>
+                      <a:prstDash val="solid"/>
+                      <a:round/>
+                      <a:headEnd type="none" w="med" len="med"/>
+                      <a:tailEnd type="none" w="med" len="med"/>
+                    </a:lnR>
+                    <a:lnT w="12700" cap="flat" cmpd="sng" algn="ctr">
+                      <a:solidFill>
+                        <a:srgbClr val="D9E2EC"/>
+                      </a:solidFill>
+                      <a:prstDash val="solid"/>
+                      <a:round/>
+                      <a:headEnd type="none" w="med" len="med"/>
+                      <a:tailEnd type="none" w="med" len="med"/>
+                    </a:lnT>
+                    <a:lnB w="12700" cap="flat" cmpd="sng" algn="ctr">
+                      <a:solidFill>
+                        <a:srgbClr val="D9E2EC"/>
+                      </a:solidFill>
+                      <a:prstDash val="solid"/>
+                      <a:round/>
+                      <a:headEnd type="none" w="med" len="med"/>
+                      <a:tailEnd type="none" w="med" len="med"/>
+                    </a:lnB>
+                    <a:solidFill>
+                      <a:srgbClr val="FFFFFF"/>
+                    </a:solidFill>
+                  </a:tcPr>
+                </a:tc>
+                <a:tc>
+                  <a:txBody>
+                    <a:bodyPr/>
+                    <a:lstStyle/>
+                    <a:p>
+                      <a:pPr indent="0" marL="0">
+                        <a:buNone/>
+                      </a:pPr>
+                      <a:r>
+                        <a:rPr lang="en-US" sz="1100" dirty="0">
+                          <a:solidFill>
+                            <a:srgbClr val="2D3748"/>
+                          </a:solidFill>
+                          <a:latin typeface="Arial" pitchFamily="34" charset="0"/>
+                          <a:ea typeface="Arial" pitchFamily="34" charset="-122"/>
+                          <a:cs typeface="Arial" pitchFamily="34" charset="-120"/>
+                        </a:rPr>
+                        <a:t>NL goal → Nova Retail login</a:t>
+                      </a:r>
+                      <a:endParaRPr lang="en-US" sz="1100" dirty="0">
+                        <a:latin typeface="Arial" charset="0"/>
+                        <a:ea typeface="Arial" charset="0"/>
+                        <a:cs typeface="Arial" charset="0"/>
+                      </a:endParaRPr>
+                    </a:p>
+                  </a:txBody>
+                  <a:tcPr marL="91440" marR="91440" marT="45720" marB="45720">
+                    <a:lnL w="12700" cap="flat" cmpd="sng" algn="ctr">
+                      <a:solidFill>
+                        <a:srgbClr val="D9E2EC"/>
+                      </a:solidFill>
+                      <a:prstDash val="solid"/>
+                      <a:round/>
+                      <a:headEnd type="none" w="med" len="med"/>
+                      <a:tailEnd type="none" w="med" len="med"/>
+                    </a:lnL>
+                    <a:lnR w="12700" cap="flat" cmpd="sng" algn="ctr">
+                      <a:solidFill>
+                        <a:srgbClr val="D9E2EC"/>
+                      </a:solidFill>
+                      <a:prstDash val="solid"/>
+                      <a:round/>
+                      <a:headEnd type="none" w="med" len="med"/>
+                      <a:tailEnd type="none" w="med" len="med"/>
+                    </a:lnR>
+                    <a:lnT w="12700" cap="flat" cmpd="sng" algn="ctr">
+                      <a:solidFill>
+                        <a:srgbClr val="D9E2EC"/>
+                      </a:solidFill>
+                      <a:prstDash val="solid"/>
+                      <a:round/>
+                      <a:headEnd type="none" w="med" len="med"/>
+                      <a:tailEnd type="none" w="med" len="med"/>
+                    </a:lnT>
+                    <a:lnB w="12700" cap="flat" cmpd="sng" algn="ctr">
+                      <a:solidFill>
+                        <a:srgbClr val="D9E2EC"/>
+                      </a:solidFill>
+                      <a:prstDash val="solid"/>
+                      <a:round/>
+                      <a:headEnd type="none" w="med" len="med"/>
+                      <a:tailEnd type="none" w="med" len="med"/>
+                    </a:lnB>
+                    <a:solidFill>
+                      <a:srgbClr val="FFFFFF"/>
+                    </a:solidFill>
+                  </a:tcPr>
+                </a:tc>
+                <a:tc>
+                  <a:txBody>
+                    <a:bodyPr/>
+                    <a:lstStyle/>
+                    <a:p>
+                      <a:pPr indent="0" marL="0">
+                        <a:buNone/>
+                      </a:pPr>
+                      <a:r>
+                        <a:rPr lang="en-US" sz="1100" dirty="0">
+                          <a:solidFill>
+                            <a:srgbClr val="2D3748"/>
+                          </a:solidFill>
+                          <a:latin typeface="Arial" pitchFamily="34" charset="0"/>
+                          <a:ea typeface="Arial" pitchFamily="34" charset="-122"/>
+                          <a:cs typeface="Arial" pitchFamily="34" charset="-120"/>
+                        </a:rPr>
+                        <a:t>runAutonomousTest()</a:t>
+                      </a:r>
+                      <a:endParaRPr lang="en-US" sz="1100" dirty="0">
+                        <a:latin typeface="Arial" charset="0"/>
+                        <a:ea typeface="Arial" charset="0"/>
+                        <a:cs typeface="Arial" charset="0"/>
+                      </a:endParaRPr>
+                    </a:p>
+                  </a:txBody>
+                  <a:tcPr marL="91440" marR="91440" marT="45720" marB="45720">
+                    <a:lnL w="12700" cap="flat" cmpd="sng" algn="ctr">
+                      <a:solidFill>
+                        <a:srgbClr val="D9E2EC"/>
+                      </a:solidFill>
+                      <a:prstDash val="solid"/>
+                      <a:round/>
+                      <a:headEnd type="none" w="med" len="med"/>
+                      <a:tailEnd type="none" w="med" len="med"/>
+                    </a:lnL>
+                    <a:lnR w="12700" cap="flat" cmpd="sng" algn="ctr">
+                      <a:solidFill>
+                        <a:srgbClr val="D9E2EC"/>
+                      </a:solidFill>
+                      <a:prstDash val="solid"/>
+                      <a:round/>
+                      <a:headEnd type="none" w="med" len="med"/>
+                      <a:tailEnd type="none" w="med" len="med"/>
+                    </a:lnR>
+                    <a:lnT w="12700" cap="flat" cmpd="sng" algn="ctr">
+                      <a:solidFill>
+                        <a:srgbClr val="D9E2EC"/>
+                      </a:solidFill>
+                      <a:prstDash val="solid"/>
+                      <a:round/>
+                      <a:headEnd type="none" w="med" len="med"/>
+                      <a:tailEnd type="none" w="med" len="med"/>
+                    </a:lnT>
+                    <a:lnB w="12700" cap="flat" cmpd="sng" algn="ctr">
+                      <a:solidFill>
+                        <a:srgbClr val="D9E2EC"/>
+                      </a:solidFill>
+                      <a:prstDash val="solid"/>
+                      <a:round/>
+                      <a:headEnd type="none" w="med" len="med"/>
+                      <a:tailEnd type="none" w="med" len="med"/>
+                    </a:lnB>
+                    <a:solidFill>
+                      <a:srgbClr val="FFFFFF"/>
+                    </a:solidFill>
+                  </a:tcPr>
+                </a:tc>
+              </a:tr>
+              <a:tr h="0">
+                <a:tc>
+                  <a:txBody>
+                    <a:bodyPr/>
+                    <a:lstStyle/>
+                    <a:p>
+                      <a:pPr indent="0" marL="0">
+                        <a:buNone/>
+                      </a:pPr>
+                      <a:r>
+                        <a:rPr lang="en-US" sz="1100" dirty="0">
+                          <a:solidFill>
+                            <a:srgbClr val="2D3748"/>
+                          </a:solidFill>
+                          <a:latin typeface="Arial" pitchFamily="34" charset="0"/>
+                          <a:ea typeface="Arial" pitchFamily="34" charset="-122"/>
+                          <a:cs typeface="Arial" pitchFamily="34" charset="-120"/>
+                        </a:rPr>
+                        <a:t>9 — Checkout</a:t>
+                      </a:r>
+                      <a:endParaRPr lang="en-US" sz="1100" dirty="0">
+                        <a:latin typeface="Arial" charset="0"/>
+                        <a:ea typeface="Arial" charset="0"/>
+                        <a:cs typeface="Arial" charset="0"/>
+                      </a:endParaRPr>
+                    </a:p>
+                  </a:txBody>
+                  <a:tcPr marL="91440" marR="91440" marT="45720" marB="45720">
+                    <a:lnL w="12700" cap="flat" cmpd="sng" algn="ctr">
+                      <a:solidFill>
+                        <a:srgbClr val="D9E2EC"/>
+                      </a:solidFill>
+                      <a:prstDash val="solid"/>
+                      <a:round/>
+                      <a:headEnd type="none" w="med" len="med"/>
+                      <a:tailEnd type="none" w="med" len="med"/>
+                    </a:lnL>
+                    <a:lnR w="12700" cap="flat" cmpd="sng" algn="ctr">
+                      <a:solidFill>
+                        <a:srgbClr val="D9E2EC"/>
+                      </a:solidFill>
+                      <a:prstDash val="solid"/>
+                      <a:round/>
+                      <a:headEnd type="none" w="med" len="med"/>
+                      <a:tailEnd type="none" w="med" len="med"/>
+                    </a:lnR>
+                    <a:lnT w="12700" cap="flat" cmpd="sng" algn="ctr">
+                      <a:solidFill>
+                        <a:srgbClr val="D9E2EC"/>
+                      </a:solidFill>
+                      <a:prstDash val="solid"/>
+                      <a:round/>
+                      <a:headEnd type="none" w="med" len="med"/>
+                      <a:tailEnd type="none" w="med" len="med"/>
+                    </a:lnT>
+                    <a:lnB w="12700" cap="flat" cmpd="sng" algn="ctr">
+                      <a:solidFill>
+                        <a:srgbClr val="D9E2EC"/>
+                      </a:solidFill>
+                      <a:prstDash val="solid"/>
+                      <a:round/>
+                      <a:headEnd type="none" w="med" len="med"/>
+                      <a:tailEnd type="none" w="med" len="med"/>
+                    </a:lnB>
+                    <a:solidFill>
+                      <a:srgbClr val="F7FAFC"/>
+                    </a:solidFill>
+                  </a:tcPr>
+                </a:tc>
+                <a:tc>
+                  <a:txBody>
+                    <a:bodyPr/>
+                    <a:lstStyle/>
+                    <a:p>
+                      <a:pPr indent="0" marL="0">
+                        <a:buNone/>
+                      </a:pPr>
+                      <a:r>
+                        <a:rPr lang="en-US" sz="1100" dirty="0">
+                          <a:solidFill>
+                            <a:srgbClr val="2D3748"/>
+                          </a:solidFill>
+                          <a:latin typeface="Arial" pitchFamily="34" charset="0"/>
+                          <a:ea typeface="Arial" pitchFamily="34" charset="-122"/>
+                          <a:cs typeface="Arial" pitchFamily="34" charset="-120"/>
+                        </a:rPr>
+                        <a:t>Add-to-cart → checkout + replan</a:t>
+                      </a:r>
+                      <a:endParaRPr lang="en-US" sz="1100" dirty="0">
+                        <a:latin typeface="Arial" charset="0"/>
+                        <a:ea typeface="Arial" charset="0"/>
+                        <a:cs typeface="Arial" charset="0"/>
+                      </a:endParaRPr>
+                    </a:p>
+                  </a:txBody>
+                  <a:tcPr marL="91440" marR="91440" marT="45720" marB="45720">
+                    <a:lnL w="12700" cap="flat" cmpd="sng" algn="ctr">
+                      <a:solidFill>
+                        <a:srgbClr val="D9E2EC"/>
+                      </a:solidFill>
+                      <a:prstDash val="solid"/>
+                      <a:round/>
+                      <a:headEnd type="none" w="med" len="med"/>
+                      <a:tailEnd type="none" w="med" len="med"/>
+                    </a:lnL>
+                    <a:lnR w="12700" cap="flat" cmpd="sng" algn="ctr">
+                      <a:solidFill>
+                        <a:srgbClr val="D9E2EC"/>
+                      </a:solidFill>
+                      <a:prstDash val="solid"/>
+                      <a:round/>
+                      <a:headEnd type="none" w="med" len="med"/>
+                      <a:tailEnd type="none" w="med" len="med"/>
+                    </a:lnR>
+                    <a:lnT w="12700" cap="flat" cmpd="sng" algn="ctr">
+                      <a:solidFill>
+                        <a:srgbClr val="D9E2EC"/>
+                      </a:solidFill>
+                      <a:prstDash val="solid"/>
+                      <a:round/>
+                      <a:headEnd type="none" w="med" len="med"/>
+                      <a:tailEnd type="none" w="med" len="med"/>
+                    </a:lnT>
+                    <a:lnB w="12700" cap="flat" cmpd="sng" algn="ctr">
+                      <a:solidFill>
+                        <a:srgbClr val="D9E2EC"/>
+                      </a:solidFill>
+                      <a:prstDash val="solid"/>
+                      <a:round/>
+                      <a:headEnd type="none" w="med" len="med"/>
+                      <a:tailEnd type="none" w="med" len="med"/>
+                    </a:lnB>
+                    <a:solidFill>
+                      <a:srgbClr val="F7FAFC"/>
+                    </a:solidFill>
+                  </a:tcPr>
+                </a:tc>
+                <a:tc>
+                  <a:txBody>
+                    <a:bodyPr/>
+                    <a:lstStyle/>
+                    <a:p>
+                      <a:pPr indent="0" marL="0">
+                        <a:buNone/>
+                      </a:pPr>
+                      <a:r>
+                        <a:rPr lang="en-US" sz="1100" dirty="0">
+                          <a:solidFill>
+                            <a:srgbClr val="2D3748"/>
+                          </a:solidFill>
+                          <a:latin typeface="Arial" pitchFamily="34" charset="0"/>
+                          <a:ea typeface="Arial" pitchFamily="34" charset="-122"/>
+                          <a:cs typeface="Arial" pitchFamily="34" charset="-120"/>
+                        </a:rPr>
+                        <a:t>maxReplans, verification agent</a:t>
+                      </a:r>
+                      <a:endParaRPr lang="en-US" sz="1100" dirty="0">
+                        <a:latin typeface="Arial" charset="0"/>
+                        <a:ea typeface="Arial" charset="0"/>
+                        <a:cs typeface="Arial" charset="0"/>
+                      </a:endParaRPr>
+                    </a:p>
+                  </a:txBody>
+                  <a:tcPr marL="91440" marR="91440" marT="45720" marB="45720">
+                    <a:lnL w="12700" cap="flat" cmpd="sng" algn="ctr">
+                      <a:solidFill>
+                        <a:srgbClr val="D9E2EC"/>
+                      </a:solidFill>
+                      <a:prstDash val="solid"/>
+                      <a:round/>
+                      <a:headEnd type="none" w="med" len="med"/>
+                      <a:tailEnd type="none" w="med" len="med"/>
+                    </a:lnL>
+                    <a:lnR w="12700" cap="flat" cmpd="sng" algn="ctr">
+                      <a:solidFill>
+                        <a:srgbClr val="D9E2EC"/>
+                      </a:solidFill>
+                      <a:prstDash val="solid"/>
+                      <a:round/>
+                      <a:headEnd type="none" w="med" len="med"/>
+                      <a:tailEnd type="none" w="med" len="med"/>
+                    </a:lnR>
+                    <a:lnT w="12700" cap="flat" cmpd="sng" algn="ctr">
+                      <a:solidFill>
+                        <a:srgbClr val="D9E2EC"/>
+                      </a:solidFill>
+                      <a:prstDash val="solid"/>
+                      <a:round/>
+                      <a:headEnd type="none" w="med" len="med"/>
+                      <a:tailEnd type="none" w="med" len="med"/>
+                    </a:lnT>
+                    <a:lnB w="12700" cap="flat" cmpd="sng" algn="ctr">
+                      <a:solidFill>
+                        <a:srgbClr val="D9E2EC"/>
+                      </a:solidFill>
+                      <a:prstDash val="solid"/>
+                      <a:round/>
+                      <a:headEnd type="none" w="med" len="med"/>
+                      <a:tailEnd type="none" w="med" len="med"/>
+                    </a:lnB>
+                    <a:solidFill>
+                      <a:srgbClr val="F7FAFC"/>
+                    </a:solidFill>
+                  </a:tcPr>
+                </a:tc>
+              </a:tr>
+              <a:tr h="0">
+                <a:tc>
+                  <a:txBody>
+                    <a:bodyPr/>
+                    <a:lstStyle/>
+                    <a:p>
+                      <a:pPr indent="0" marL="0">
+                        <a:buNone/>
+                      </a:pPr>
+                      <a:r>
+                        <a:rPr lang="en-US" sz="1100" dirty="0">
+                          <a:solidFill>
+                            <a:srgbClr val="2D3748"/>
+                          </a:solidFill>
+                          <a:latin typeface="Arial" pitchFamily="34" charset="0"/>
+                          <a:ea typeface="Arial" pitchFamily="34" charset="-122"/>
+                          <a:cs typeface="Arial" pitchFamily="34" charset="-120"/>
+                        </a:rPr>
+                        <a:t>10 — Governance</a:t>
+                      </a:r>
+                      <a:endParaRPr lang="en-US" sz="1100" dirty="0">
+                        <a:latin typeface="Arial" charset="0"/>
+                        <a:ea typeface="Arial" charset="0"/>
+                        <a:cs typeface="Arial" charset="0"/>
+                      </a:endParaRPr>
+                    </a:p>
+                  </a:txBody>
+                  <a:tcPr marL="91440" marR="91440" marT="45720" marB="45720">
+                    <a:lnL w="12700" cap="flat" cmpd="sng" algn="ctr">
+                      <a:solidFill>
+                        <a:srgbClr val="D9E2EC"/>
+                      </a:solidFill>
+                      <a:prstDash val="solid"/>
+                      <a:round/>
+                      <a:headEnd type="none" w="med" len="med"/>
+                      <a:tailEnd type="none" w="med" len="med"/>
+                    </a:lnL>
+                    <a:lnR w="12700" cap="flat" cmpd="sng" algn="ctr">
+                      <a:solidFill>
+                        <a:srgbClr val="D9E2EC"/>
+                      </a:solidFill>
+                      <a:prstDash val="solid"/>
+                      <a:round/>
+                      <a:headEnd type="none" w="med" len="med"/>
+                      <a:tailEnd type="none" w="med" len="med"/>
+                    </a:lnR>
+                    <a:lnT w="12700" cap="flat" cmpd="sng" algn="ctr">
+                      <a:solidFill>
+                        <a:srgbClr val="D9E2EC"/>
+                      </a:solidFill>
+                      <a:prstDash val="solid"/>
+                      <a:round/>
+                      <a:headEnd type="none" w="med" len="med"/>
+                      <a:tailEnd type="none" w="med" len="med"/>
+                    </a:lnT>
+                    <a:lnB w="12700" cap="flat" cmpd="sng" algn="ctr">
+                      <a:solidFill>
+                        <a:srgbClr val="D9E2EC"/>
+                      </a:solidFill>
+                      <a:prstDash val="solid"/>
+                      <a:round/>
+                      <a:headEnd type="none" w="med" len="med"/>
+                      <a:tailEnd type="none" w="med" len="med"/>
+                    </a:lnB>
+                    <a:solidFill>
+                      <a:srgbClr val="FFFFFF"/>
+                    </a:solidFill>
+                  </a:tcPr>
+                </a:tc>
+                <a:tc>
+                  <a:txBody>
+                    <a:bodyPr/>
+                    <a:lstStyle/>
+                    <a:p>
+                      <a:pPr indent="0" marL="0">
+                        <a:buNone/>
+                      </a:pPr>
+                      <a:r>
+                        <a:rPr lang="en-US" sz="1100" dirty="0">
+                          <a:solidFill>
+                            <a:srgbClr val="2D3748"/>
+                          </a:solidFill>
+                          <a:latin typeface="Arial" pitchFamily="34" charset="0"/>
+                          <a:ea typeface="Arial" pitchFamily="34" charset="-122"/>
+                          <a:cs typeface="Arial" pitchFamily="34" charset="-120"/>
+                        </a:rPr>
+                        <a:t>Secrets, cost caps, CI smoke</a:t>
+                      </a:r>
+                      <a:endParaRPr lang="en-US" sz="1100" dirty="0">
+                        <a:latin typeface="Arial" charset="0"/>
+                        <a:ea typeface="Arial" charset="0"/>
+                        <a:cs typeface="Arial" charset="0"/>
+                      </a:endParaRPr>
+                    </a:p>
+                  </a:txBody>
+                  <a:tcPr marL="91440" marR="91440" marT="45720" marB="45720">
+                    <a:lnL w="12700" cap="flat" cmpd="sng" algn="ctr">
+                      <a:solidFill>
+                        <a:srgbClr val="D9E2EC"/>
+                      </a:solidFill>
+                      <a:prstDash val="solid"/>
+                      <a:round/>
+                      <a:headEnd type="none" w="med" len="med"/>
+                      <a:tailEnd type="none" w="med" len="med"/>
+                    </a:lnL>
+                    <a:lnR w="12700" cap="flat" cmpd="sng" algn="ctr">
+                      <a:solidFill>
+                        <a:srgbClr val="D9E2EC"/>
+                      </a:solidFill>
+                      <a:prstDash val="solid"/>
+                      <a:round/>
+                      <a:headEnd type="none" w="med" len="med"/>
+                      <a:tailEnd type="none" w="med" len="med"/>
+                    </a:lnR>
+                    <a:lnT w="12700" cap="flat" cmpd="sng" algn="ctr">
+                      <a:solidFill>
+                        <a:srgbClr val="D9E2EC"/>
+                      </a:solidFill>
+                      <a:prstDash val="solid"/>
+                      <a:round/>
+                      <a:headEnd type="none" w="med" len="med"/>
+                      <a:tailEnd type="none" w="med" len="med"/>
+                    </a:lnT>
+                    <a:lnB w="12700" cap="flat" cmpd="sng" algn="ctr">
+                      <a:solidFill>
+                        <a:srgbClr val="D9E2EC"/>
+                      </a:solidFill>
+                      <a:prstDash val="solid"/>
+                      <a:round/>
+                      <a:headEnd type="none" w="med" len="med"/>
+                      <a:tailEnd type="none" w="med" len="med"/>
+                    </a:lnB>
+                    <a:solidFill>
+                      <a:srgbClr val="FFFFFF"/>
+                    </a:solidFill>
+                  </a:tcPr>
+                </a:tc>
+                <a:tc>
+                  <a:txBody>
+                    <a:bodyPr/>
+                    <a:lstStyle/>
+                    <a:p>
+                      <a:pPr indent="0" marL="0">
+                        <a:buNone/>
+                      </a:pPr>
+                      <a:r>
+                        <a:rPr lang="en-US" sz="1100" dirty="0">
+                          <a:solidFill>
+                            <a:srgbClr val="2D3748"/>
+                          </a:solidFill>
+                          <a:latin typeface="Arial" pitchFamily="34" charset="0"/>
+                          <a:ea typeface="Arial" pitchFamily="34" charset="-122"/>
+                          <a:cs typeface="Arial" pitchFamily="34" charset="-120"/>
+                        </a:rPr>
+                        <a:t>runAutonomousSuite(), KPIs JSON</a:t>
+                      </a:r>
+                      <a:endParaRPr lang="en-US" sz="1100" dirty="0">
+                        <a:latin typeface="Arial" charset="0"/>
+                        <a:ea typeface="Arial" charset="0"/>
+                        <a:cs typeface="Arial" charset="0"/>
+                      </a:endParaRPr>
+                    </a:p>
+                  </a:txBody>
+                  <a:tcPr marL="91440" marR="91440" marT="45720" marB="45720">
+                    <a:lnL w="12700" cap="flat" cmpd="sng" algn="ctr">
+                      <a:solidFill>
+                        <a:srgbClr val="D9E2EC"/>
+                      </a:solidFill>
+                      <a:prstDash val="solid"/>
+                      <a:round/>
+                      <a:headEnd type="none" w="med" len="med"/>
+                      <a:tailEnd type="none" w="med" len="med"/>
+                    </a:lnL>
+                    <a:lnR w="12700" cap="flat" cmpd="sng" algn="ctr">
+                      <a:solidFill>
+                        <a:srgbClr val="D9E2EC"/>
+                      </a:solidFill>
+                      <a:prstDash val="solid"/>
+                      <a:round/>
+                      <a:headEnd type="none" w="med" len="med"/>
+                      <a:tailEnd type="none" w="med" len="med"/>
+                    </a:lnR>
+                    <a:lnT w="12700" cap="flat" cmpd="sng" algn="ctr">
+                      <a:solidFill>
+                        <a:srgbClr val="D9E2EC"/>
+                      </a:solidFill>
+                      <a:prstDash val="solid"/>
+                      <a:round/>
+                      <a:headEnd type="none" w="med" len="med"/>
+                      <a:tailEnd type="none" w="med" len="med"/>
+                    </a:lnT>
+                    <a:lnB w="12700" cap="flat" cmpd="sng" algn="ctr">
+                      <a:solidFill>
+                        <a:srgbClr val="D9E2EC"/>
+                      </a:solidFill>
+                      <a:prstDash val="solid"/>
+                      <a:round/>
+                      <a:headEnd type="none" w="med" len="med"/>
+                      <a:tailEnd type="none" w="med" len="med"/>
+                    </a:lnB>
+                    <a:solidFill>
+                      <a:srgbClr val="FFFFFF"/>
+                    </a:solidFill>
+                  </a:tcPr>
+                </a:tc>
+              </a:tr>
+              <a:tr h="0">
+                <a:tc>
+                  <a:txBody>
+                    <a:bodyPr/>
+                    <a:lstStyle/>
+                    <a:p>
+                      <a:pPr indent="0" marL="0">
+                        <a:buNone/>
+                      </a:pPr>
+                      <a:r>
+                        <a:rPr lang="en-US" sz="1100" dirty="0">
+                          <a:solidFill>
+                            <a:srgbClr val="2D3748"/>
+                          </a:solidFill>
+                          <a:latin typeface="Arial" pitchFamily="34" charset="0"/>
+                          <a:ea typeface="Arial" pitchFamily="34" charset="-122"/>
+                          <a:cs typeface="Arial" pitchFamily="34" charset="-120"/>
+                        </a:rPr>
+                        <a:t>11 — Maintenance</a:t>
+                      </a:r>
+                      <a:endParaRPr lang="en-US" sz="1100" dirty="0">
+                        <a:latin typeface="Arial" charset="0"/>
+                        <a:ea typeface="Arial" charset="0"/>
+                        <a:cs typeface="Arial" charset="0"/>
+                      </a:endParaRPr>
+                    </a:p>
+                  </a:txBody>
+                  <a:tcPr marL="91440" marR="91440" marT="45720" marB="45720">
+                    <a:lnL w="12700" cap="flat" cmpd="sng" algn="ctr">
+                      <a:solidFill>
+                        <a:srgbClr val="D9E2EC"/>
+                      </a:solidFill>
+                      <a:prstDash val="solid"/>
+                      <a:round/>
+                      <a:headEnd type="none" w="med" len="med"/>
+                      <a:tailEnd type="none" w="med" len="med"/>
+                    </a:lnL>
+                    <a:lnR w="12700" cap="flat" cmpd="sng" algn="ctr">
+                      <a:solidFill>
+                        <a:srgbClr val="D9E2EC"/>
+                      </a:solidFill>
+                      <a:prstDash val="solid"/>
+                      <a:round/>
+                      <a:headEnd type="none" w="med" len="med"/>
+                      <a:tailEnd type="none" w="med" len="med"/>
+                    </a:lnR>
+                    <a:lnT w="12700" cap="flat" cmpd="sng" algn="ctr">
+                      <a:solidFill>
+                        <a:srgbClr val="D9E2EC"/>
+                      </a:solidFill>
+                      <a:prstDash val="solid"/>
+                      <a:round/>
+                      <a:headEnd type="none" w="med" len="med"/>
+                      <a:tailEnd type="none" w="med" len="med"/>
+                    </a:lnT>
+                    <a:lnB w="12700" cap="flat" cmpd="sng" algn="ctr">
+                      <a:solidFill>
+                        <a:srgbClr val="D9E2EC"/>
+                      </a:solidFill>
+                      <a:prstDash val="solid"/>
+                      <a:round/>
+                      <a:headEnd type="none" w="med" len="med"/>
+                      <a:tailEnd type="none" w="med" len="med"/>
+                    </a:lnB>
+                    <a:solidFill>
+                      <a:srgbClr val="F7FAFC"/>
+                    </a:solidFill>
+                  </a:tcPr>
+                </a:tc>
+                <a:tc>
+                  <a:txBody>
+                    <a:bodyPr/>
+                    <a:lstStyle/>
+                    <a:p>
+                      <a:pPr indent="0" marL="0">
+                        <a:buNone/>
+                      </a:pPr>
+                      <a:r>
+                        <a:rPr lang="en-US" sz="1100" dirty="0">
+                          <a:solidFill>
+                            <a:srgbClr val="2D3748"/>
+                          </a:solidFill>
+                          <a:latin typeface="Arial" pitchFamily="34" charset="0"/>
+                          <a:ea typeface="Arial" pitchFamily="34" charset="-122"/>
+                          <a:cs typeface="Arial" pitchFamily="34" charset="-120"/>
+                        </a:rPr>
+                        <a:t>Patches + Jira on repeat failures</a:t>
+                      </a:r>
+                      <a:endParaRPr lang="en-US" sz="1100" dirty="0">
+                        <a:latin typeface="Arial" charset="0"/>
+                        <a:ea typeface="Arial" charset="0"/>
+                        <a:cs typeface="Arial" charset="0"/>
+                      </a:endParaRPr>
+                    </a:p>
+                  </a:txBody>
+                  <a:tcPr marL="91440" marR="91440" marT="45720" marB="45720">
+                    <a:lnL w="12700" cap="flat" cmpd="sng" algn="ctr">
+                      <a:solidFill>
+                        <a:srgbClr val="D9E2EC"/>
+                      </a:solidFill>
+                      <a:prstDash val="solid"/>
+                      <a:round/>
+                      <a:headEnd type="none" w="med" len="med"/>
+                      <a:tailEnd type="none" w="med" len="med"/>
+                    </a:lnL>
+                    <a:lnR w="12700" cap="flat" cmpd="sng" algn="ctr">
+                      <a:solidFill>
+                        <a:srgbClr val="D9E2EC"/>
+                      </a:solidFill>
+                      <a:prstDash val="solid"/>
+                      <a:round/>
+                      <a:headEnd type="none" w="med" len="med"/>
+                      <a:tailEnd type="none" w="med" len="med"/>
+                    </a:lnR>
+                    <a:lnT w="12700" cap="flat" cmpd="sng" algn="ctr">
+                      <a:solidFill>
+                        <a:srgbClr val="D9E2EC"/>
+                      </a:solidFill>
+                      <a:prstDash val="solid"/>
+                      <a:round/>
+                      <a:headEnd type="none" w="med" len="med"/>
+                      <a:tailEnd type="none" w="med" len="med"/>
+                    </a:lnT>
+                    <a:lnB w="12700" cap="flat" cmpd="sng" algn="ctr">
+                      <a:solidFill>
+                        <a:srgbClr val="D9E2EC"/>
+                      </a:solidFill>
+                      <a:prstDash val="solid"/>
+                      <a:round/>
+                      <a:headEnd type="none" w="med" len="med"/>
+                      <a:tailEnd type="none" w="med" len="med"/>
+                    </a:lnB>
+                    <a:solidFill>
+                      <a:srgbClr val="F7FAFC"/>
+                    </a:solidFill>
+                  </a:tcPr>
+                </a:tc>
+                <a:tc>
+                  <a:txBody>
+                    <a:bodyPr/>
+                    <a:lstStyle/>
+                    <a:p>
+                      <a:pPr indent="0" marL="0">
+                        <a:buNone/>
+                      </a:pPr>
+                      <a:r>
+                        <a:rPr lang="en-US" sz="1100" dirty="0">
+                          <a:solidFill>
+                            <a:srgbClr val="2D3748"/>
+                          </a:solidFill>
+                          <a:latin typeface="Arial" pitchFamily="34" charset="0"/>
+                          <a:ea typeface="Arial" pitchFamily="34" charset="-122"/>
+                          <a:cs typeface="Arial" pitchFamily="34" charset="-120"/>
+                        </a:rPr>
+                        <a:t>runMaintenanceAgentAsync()</a:t>
+                      </a:r>
+                      <a:endParaRPr lang="en-US" sz="1100" dirty="0">
+                        <a:latin typeface="Arial" charset="0"/>
+                        <a:ea typeface="Arial" charset="0"/>
+                        <a:cs typeface="Arial" charset="0"/>
+                      </a:endParaRPr>
+                    </a:p>
+                  </a:txBody>
+                  <a:tcPr marL="91440" marR="91440" marT="45720" marB="45720">
+                    <a:lnL w="12700" cap="flat" cmpd="sng" algn="ctr">
+                      <a:solidFill>
+                        <a:srgbClr val="D9E2EC"/>
+                      </a:solidFill>
+                      <a:prstDash val="solid"/>
+                      <a:round/>
+                      <a:headEnd type="none" w="med" len="med"/>
+                      <a:tailEnd type="none" w="med" len="med"/>
+                    </a:lnL>
+                    <a:lnR w="12700" cap="flat" cmpd="sng" algn="ctr">
+                      <a:solidFill>
+                        <a:srgbClr val="D9E2EC"/>
+                      </a:solidFill>
+                      <a:prstDash val="solid"/>
+                      <a:round/>
+                      <a:headEnd type="none" w="med" len="med"/>
+                      <a:tailEnd type="none" w="med" len="med"/>
+                    </a:lnR>
+                    <a:lnT w="12700" cap="flat" cmpd="sng" algn="ctr">
+                      <a:solidFill>
+                        <a:srgbClr val="D9E2EC"/>
+                      </a:solidFill>
+                      <a:prstDash val="solid"/>
+                      <a:round/>
+                      <a:headEnd type="none" w="med" len="med"/>
+                      <a:tailEnd type="none" w="med" len="med"/>
+                    </a:lnT>
+                    <a:lnB w="12700" cap="flat" cmpd="sng" algn="ctr">
+                      <a:solidFill>
+                        <a:srgbClr val="D9E2EC"/>
+                      </a:solidFill>
+                      <a:prstDash val="solid"/>
+                      <a:round/>
+                      <a:headEnd type="none" w="med" len="med"/>
+                      <a:tailEnd type="none" w="med" len="med"/>
+                    </a:lnB>
+                    <a:solidFill>
+                      <a:srgbClr val="F7FAFC"/>
+                    </a:solidFill>
+                  </a:tcPr>
+                </a:tc>
+              </a:tr>
+            </a:tbl>
+          </a:graphicData>
+        </a:graphic>
+      </p:graphicFrame>
+      <p:sp>
+        <p:nvSpPr>
+          <p:cNvPr id="5" name="Text 2"/>
+          <p:cNvSpPr/>
+          <p:nvPr/>
+        </p:nvSpPr>
+        <p:spPr>
+          <a:xfrm>
+            <a:off x="640080" y="4754880"/>
+            <a:ext cx="10972800" cy="365760"/>
+          </a:xfrm>
+          <a:prstGeom prst="rect">
+            <a:avLst/>
+          </a:prstGeom>
+          <a:noFill/>
+          <a:ln/>
+        </p:spPr>
+        <p:txBody>
+          <a:bodyPr wrap="square" rtlCol="0" anchor="ctr"/>
+          <a:lstStyle/>
+          <a:p>
+            <a:pPr algn="ctr" indent="0" marL="0">
+              <a:buNone/>
+            </a:pPr>
+            <a:r>
+              <a:rPr lang="en-US" sz="1000" i="1" dirty="0">
+                <a:solidFill>
+                  <a:srgbClr val="718096"/>
+                </a:solidFill>
+                <a:latin typeface="Arial" pitchFamily="34" charset="0"/>
+                <a:ea typeface="Arial" pitchFamily="34" charset="-122"/>
+                <a:cs typeface="Arial" pitchFamily="34" charset="-120"/>
+              </a:rPr>
+              <a:t>PRD: docs/PRD-Fully-Autonomous-AI-Agent.md</a:t>
+            </a:r>
+            <a:endParaRPr lang="en-US" sz="1000" dirty="0"/>
+          </a:p>
+        </p:txBody>
+      </p:sp>
+    </p:spTree>
+  </p:cSld>
+  <p:clrMapOvr>
+    <a:masterClrMapping/>
+  </p:clrMapOvr>
+</p:sld>
+</file>
+
+<file path=ppt/slides/slide22.xml><?xml version="1.0" encoding="utf-8"?>
+<p:sld xmlns:a="http://schemas.openxmlformats.org/drawingml/2006/main" xmlns:r="http://schemas.openxmlformats.org/officeDocument/2006/relationships" xmlns:p="http://schemas.openxmlformats.org/presentationml/2006/main">
+  <p:cSld name="Slide 22">
+    <p:spTree>
+      <p:nvGrpSpPr>
+        <p:cNvPr id="1" name=""/>
+        <p:cNvGrpSpPr/>
+        <p:nvPr/>
+      </p:nvGrpSpPr>
+      <p:grpSpPr>
+        <a:xfrm>
+          <a:off x="0" y="0"/>
+          <a:ext cx="0" cy="0"/>
+          <a:chOff x="0" y="0"/>
+          <a:chExt cx="0" cy="0"/>
+        </a:xfrm>
+      </p:grpSpPr>
+      <p:sp>
+        <p:nvSpPr>
+          <p:cNvPr id="2" name="Shape 0"/>
+          <p:cNvSpPr/>
+          <p:nvPr/>
+        </p:nvSpPr>
+        <p:spPr>
+          <a:xfrm>
+            <a:off x="0" y="0"/>
+            <a:ext cx="12188952" cy="256032"/>
+          </a:xfrm>
+          <a:prstGeom prst="rect">
+            <a:avLst/>
+          </a:prstGeom>
+          <a:solidFill>
+            <a:srgbClr val="2F6FB0"/>
+          </a:solidFill>
+          <a:ln w="12700">
+            <a:solidFill>
+              <a:srgbClr val="333333"/>
+            </a:solidFill>
+            <a:prstDash val="solid"/>
+          </a:ln>
+        </p:spPr>
+      </p:sp>
+      <p:sp>
+        <p:nvSpPr>
+          <p:cNvPr id="3" name="Text 1"/>
+          <p:cNvSpPr/>
+          <p:nvPr/>
+        </p:nvSpPr>
+        <p:spPr>
+          <a:xfrm>
+            <a:off x="548640" y="411480"/>
+            <a:ext cx="10972800" cy="548640"/>
+          </a:xfrm>
+          <a:prstGeom prst="rect">
+            <a:avLst/>
+          </a:prstGeom>
+          <a:noFill/>
+          <a:ln/>
+        </p:spPr>
+        <p:txBody>
+          <a:bodyPr wrap="square" rtlCol="0" anchor="ctr"/>
+          <a:lstStyle/>
+          <a:p>
+            <a:pPr indent="0" marL="0">
+              <a:buNone/>
+            </a:pPr>
+            <a:r>
+              <a:rPr lang="en-US" sz="2100" b="1" dirty="0">
+                <a:solidFill>
+                  <a:srgbClr val="1B365D"/>
+                </a:solidFill>
+                <a:latin typeface="Arial" pitchFamily="34" charset="0"/>
+                <a:ea typeface="Arial" pitchFamily="34" charset="-122"/>
+                <a:cs typeface="Arial" pitchFamily="34" charset="-120"/>
+              </a:rPr>
+              <a:t>Phase 8–11 — How to Demo</a:t>
+            </a:r>
+            <a:endParaRPr lang="en-US" sz="2100" dirty="0"/>
+          </a:p>
+        </p:txBody>
+      </p:sp>
+      <p:sp>
+        <p:nvSpPr>
+          <p:cNvPr id="4" name="Text 2"/>
+          <p:cNvSpPr/>
+          <p:nvPr/>
+        </p:nvSpPr>
+        <p:spPr>
+          <a:xfrm>
+            <a:off x="640080" y="1097280"/>
+            <a:ext cx="10972800" cy="3749040"/>
+          </a:xfrm>
+          <a:prstGeom prst="rect">
+            <a:avLst/>
+          </a:prstGeom>
+          <a:noFill/>
+          <a:ln/>
+        </p:spPr>
+        <p:txBody>
+          <a:bodyPr wrap="square" rtlCol="0" anchor="ctr"/>
+          <a:lstStyle/>
+          <a:p>
+            <a:pPr marL="342900" indent="-342900">
+              <a:lnSpc>
+                <a:spcPct val="116000"/>
+              </a:lnSpc>
+              <a:buSzPct val="100000"/>
+              <a:buChar char="•"/>
+            </a:pPr>
+            <a:r>
+              <a:rPr lang="en-US" sz="1300" dirty="0">
+                <a:solidFill>
+                  <a:srgbClr val="2D3748"/>
+                </a:solidFill>
+                <a:latin typeface="Arial" pitchFamily="34" charset="0"/>
+                <a:ea typeface="Arial" pitchFamily="34" charset="-122"/>
+                <a:cs typeface="Arial" pitchFamily="34" charset="-120"/>
+              </a:rPr>
+              <a:t>npm run test:autonomous-login — single NL login goal</a:t>
+            </a:r>
+            <a:endParaRPr lang="en-US" sz="1300" dirty="0"/>
+          </a:p>
+          <a:p>
+            <a:pPr marL="342900" indent="-342900">
+              <a:lnSpc>
+                <a:spcPct val="116000"/>
+              </a:lnSpc>
+              <a:buSzPct val="100000"/>
+              <a:buChar char="•"/>
+            </a:pPr>
+            <a:r>
+              <a:rPr lang="en-US" sz="1300" dirty="0">
+                <a:solidFill>
+                  <a:srgbClr val="2D3748"/>
+                </a:solidFill>
+                <a:latin typeface="Arial" pitchFamily="34" charset="0"/>
+                <a:ea typeface="Arial" pitchFamily="34" charset="-122"/>
+                <a:cs typeface="Arial" pitchFamily="34" charset="-120"/>
+              </a:rPr>
+              <a:t>npm run test:autonomous-checkout — login + cart + checkout journey</a:t>
+            </a:r>
+            <a:endParaRPr lang="en-US" sz="1300" dirty="0"/>
+          </a:p>
+          <a:p>
+            <a:pPr marL="342900" indent="-342900">
+              <a:lnSpc>
+                <a:spcPct val="116000"/>
+              </a:lnSpc>
+              <a:buSzPct val="100000"/>
+              <a:buChar char="•"/>
+            </a:pPr>
+            <a:r>
+              <a:rPr lang="en-US" sz="1300" dirty="0">
+                <a:solidFill>
+                  <a:srgbClr val="2D3748"/>
+                </a:solidFill>
+                <a:latin typeface="Arial" pitchFamily="34" charset="0"/>
+                <a:ea typeface="Arial" pitchFamily="34" charset="-122"/>
+                <a:cs typeface="Arial" pitchFamily="34" charset="-120"/>
+              </a:rPr>
+              <a:t>npm run test:autonomous-ci-smoke — governed 2-journey suite with env secrets</a:t>
+            </a:r>
+            <a:endParaRPr lang="en-US" sz="1300" dirty="0"/>
+          </a:p>
+          <a:p>
+            <a:pPr marL="342900" indent="-342900">
+              <a:lnSpc>
+                <a:spcPct val="116000"/>
+              </a:lnSpc>
+              <a:buSzPct val="100000"/>
+              <a:buChar char="•"/>
+            </a:pPr>
+            <a:r>
+              <a:rPr lang="en-US" sz="1300" dirty="0">
+                <a:solidFill>
+                  <a:srgbClr val="2D3748"/>
+                </a:solidFill>
+                <a:latin typeface="Arial" pitchFamily="34" charset="0"/>
+                <a:ea typeface="Arial" pitchFamily="34" charset="-122"/>
+                <a:cs typeface="Arial" pitchFamily="34" charset="-120"/>
+              </a:rPr>
+              <a:t>MAINTENANCE_AGENT=1 — failure tracking + locator patch proposals</a:t>
+            </a:r>
+            <a:endParaRPr lang="en-US" sz="1300" dirty="0"/>
+          </a:p>
+          <a:p>
+            <a:pPr marL="342900" indent="-342900">
+              <a:lnSpc>
+                <a:spcPct val="116000"/>
+              </a:lnSpc>
+              <a:buSzPct val="100000"/>
+              <a:buChar char="•"/>
+            </a:pPr>
+            <a:r>
+              <a:rPr lang="en-US" sz="1300" dirty="0">
+                <a:solidFill>
+                  <a:srgbClr val="2D3748"/>
+                </a:solidFill>
+                <a:latin typeface="Arial" pitchFamily="34" charset="0"/>
+                <a:ea typeface="Arial" pitchFamily="34" charset="-122"/>
+                <a:cs typeface="Arial" pitchFamily="34" charset="-120"/>
+              </a:rPr>
+              <a:t>MAINTENANCE_PUBLISH_JIRA=1 + JIRA_* — live Jira ticket on repeated failures</a:t>
+            </a:r>
+            <a:endParaRPr lang="en-US" sz="1300" dirty="0"/>
+          </a:p>
+          <a:p>
+            <a:pPr marL="342900" indent="-342900">
+              <a:lnSpc>
+                <a:spcPct val="116000"/>
+              </a:lnSpc>
+              <a:buSzPct val="100000"/>
+              <a:buChar char="•"/>
+            </a:pPr>
+            <a:r>
+              <a:rPr lang="en-US" sz="1300" dirty="0">
+                <a:solidFill>
+                  <a:srgbClr val="2D3748"/>
+                </a:solidFill>
+                <a:latin typeface="Arial" pitchFamily="34" charset="0"/>
+                <a:ea typeface="Arial" pitchFamily="34" charset="-122"/>
+                <a:cs typeface="Arial" pitchFamily="34" charset="-120"/>
+              </a:rPr>
+              <a:t>npm run deck:agentic — regenerate this deck</a:t>
+            </a:r>
+            <a:endParaRPr lang="en-US" sz="1300" dirty="0"/>
+          </a:p>
+        </p:txBody>
+      </p:sp>
+    </p:spTree>
+  </p:cSld>
+  <p:clrMapOvr>
+    <a:masterClrMapping/>
+  </p:clrMapOvr>
+</p:sld>
+</file>
+
+<file path=ppt/slides/slide23.xml><?xml version="1.0" encoding="utf-8"?>
+<p:sld xmlns:a="http://schemas.openxmlformats.org/drawingml/2006/main" xmlns:r="http://schemas.openxmlformats.org/officeDocument/2006/relationships" xmlns:p="http://schemas.openxmlformats.org/presentationml/2006/main">
+  <p:cSld name="Slide 23">
+    <p:spTree>
+      <p:nvGrpSpPr>
+        <p:cNvPr id="1" name=""/>
+        <p:cNvGrpSpPr/>
+        <p:nvPr/>
+      </p:nvGrpSpPr>
+      <p:grpSpPr>
+        <a:xfrm>
+          <a:off x="0" y="0"/>
+          <a:ext cx="0" cy="0"/>
+          <a:chOff x="0" y="0"/>
+          <a:chExt cx="0" cy="0"/>
+        </a:xfrm>
+      </p:grpSpPr>
+      <p:sp>
+        <p:nvSpPr>
+          <p:cNvPr id="2" name="Shape 0"/>
+          <p:cNvSpPr/>
+          <p:nvPr/>
+        </p:nvSpPr>
+        <p:spPr>
+          <a:xfrm>
+            <a:off x="0" y="0"/>
+            <a:ext cx="12188952" cy="256032"/>
+          </a:xfrm>
+          <a:prstGeom prst="rect">
+            <a:avLst/>
+          </a:prstGeom>
+          <a:solidFill>
+            <a:srgbClr val="2F6FB0"/>
+          </a:solidFill>
+          <a:ln w="12700">
+            <a:solidFill>
+              <a:srgbClr val="333333"/>
+            </a:solidFill>
+            <a:prstDash val="solid"/>
+          </a:ln>
+        </p:spPr>
+      </p:sp>
+      <p:sp>
+        <p:nvSpPr>
+          <p:cNvPr id="3" name="Text 1"/>
+          <p:cNvSpPr/>
+          <p:nvPr/>
+        </p:nvSpPr>
+        <p:spPr>
+          <a:xfrm>
+            <a:off x="548640" y="411480"/>
+            <a:ext cx="10972800" cy="548640"/>
+          </a:xfrm>
+          <a:prstGeom prst="rect">
+            <a:avLst/>
+          </a:prstGeom>
+          <a:noFill/>
+          <a:ln/>
+        </p:spPr>
+        <p:txBody>
+          <a:bodyPr wrap="square" rtlCol="0" anchor="ctr"/>
+          <a:lstStyle/>
+          <a:p>
+            <a:pPr indent="0" marL="0">
+              <a:buNone/>
+            </a:pPr>
+            <a:r>
+              <a:rPr lang="en-US" sz="2100" b="1" dirty="0">
+                <a:solidFill>
+                  <a:srgbClr val="1B365D"/>
+                </a:solidFill>
+                <a:latin typeface="Arial" pitchFamily="34" charset="0"/>
+                <a:ea typeface="Arial" pitchFamily="34" charset="-122"/>
+                <a:cs typeface="Arial" pitchFamily="34" charset="-120"/>
+              </a:rPr>
+              <a:t>Future Enhancements</a:t>
+            </a:r>
+            <a:endParaRPr lang="en-US" sz="2100" dirty="0"/>
+          </a:p>
+        </p:txBody>
+      </p:sp>
+      <p:sp>
+        <p:nvSpPr>
+          <p:cNvPr id="4" name="Text 2"/>
+          <p:cNvSpPr/>
+          <p:nvPr/>
+        </p:nvSpPr>
+        <p:spPr>
+          <a:xfrm>
+            <a:off x="640080" y="1097280"/>
+            <a:ext cx="10972800" cy="3749040"/>
+          </a:xfrm>
+          <a:prstGeom prst="rect">
+            <a:avLst/>
+          </a:prstGeom>
+          <a:noFill/>
+          <a:ln/>
+        </p:spPr>
+        <p:txBody>
+          <a:bodyPr wrap="square" rtlCol="0" anchor="ctr"/>
+          <a:lstStyle/>
+          <a:p>
+            <a:pPr marL="342900" indent="-342900">
+              <a:lnSpc>
+                <a:spcPct val="116000"/>
+              </a:lnSpc>
+              <a:buSzPct val="100000"/>
+              <a:buChar char="•"/>
+            </a:pPr>
+            <a:r>
+              <a:rPr lang="en-US" sz="1300" dirty="0">
+                <a:solidFill>
+                  <a:srgbClr val="2D3748"/>
+                </a:solidFill>
+                <a:latin typeface="Arial" pitchFamily="34" charset="0"/>
+                <a:ea typeface="Arial" pitchFamily="34" charset="-122"/>
+                <a:cs typeface="Arial" pitchFamily="34" charset="-120"/>
+              </a:rPr>
+              <a:t>Vision agent — screenshot analysis for canvas/shadow DOM cases.</a:t>
+            </a:r>
+            <a:endParaRPr lang="en-US" sz="1300" dirty="0"/>
+          </a:p>
+          <a:p>
+            <a:pPr marL="342900" indent="-342900">
+              <a:lnSpc>
+                <a:spcPct val="116000"/>
+              </a:lnSpc>
+              <a:buSzPct val="100000"/>
+              <a:buChar char="•"/>
+            </a:pPr>
+            <a:r>
+              <a:rPr lang="en-US" sz="1300" dirty="0">
+                <a:solidFill>
+                  <a:srgbClr val="2D3748"/>
+                </a:solidFill>
+                <a:latin typeface="Arial" pitchFamily="34" charset="0"/>
+                <a:ea typeface="Arial" pitchFamily="34" charset="-122"/>
+                <a:cs typeface="Arial" pitchFamily="34" charset="-120"/>
+              </a:rPr>
+              <a:t>Hosted healing-service SaaS for enterprise adopters.</a:t>
+            </a:r>
+            <a:endParaRPr lang="en-US" sz="1300" dirty="0"/>
+          </a:p>
+          <a:p>
+            <a:pPr marL="342900" indent="-342900">
+              <a:lnSpc>
+                <a:spcPct val="116000"/>
+              </a:lnSpc>
+              <a:buSzPct val="100000"/>
+              <a:buChar char="•"/>
+            </a:pPr>
+            <a:r>
+              <a:rPr lang="en-US" sz="1300" dirty="0">
+                <a:solidFill>
+                  <a:srgbClr val="2D3748"/>
+                </a:solidFill>
+                <a:latin typeface="Arial" pitchFamily="34" charset="0"/>
+                <a:ea typeface="Arial" pitchFamily="34" charset="-122"/>
+                <a:cs typeface="Arial" pitchFamily="34" charset="-120"/>
+              </a:rPr>
+              <a:t>npm publish ai-healing-sdk@2.x with migration guide.</a:t>
+            </a:r>
+            <a:endParaRPr lang="en-US" sz="1300" dirty="0"/>
+          </a:p>
+          <a:p>
+            <a:pPr marL="342900" indent="-342900">
+              <a:lnSpc>
+                <a:spcPct val="116000"/>
+              </a:lnSpc>
+              <a:buSzPct val="100000"/>
+              <a:buChar char="•"/>
+            </a:pPr>
+            <a:r>
+              <a:rPr lang="en-US" sz="1300" dirty="0">
+                <a:solidFill>
+                  <a:srgbClr val="2D3748"/>
+                </a:solidFill>
+                <a:latin typeface="Arial" pitchFamily="34" charset="0"/>
+                <a:ea typeface="Arial" pitchFamily="34" charset="-122"/>
+                <a:cs typeface="Arial" pitchFamily="34" charset="-120"/>
+              </a:rPr>
+              <a:t>Linear live publish (parallel to Jira integration).</a:t>
+            </a:r>
+            <a:endParaRPr lang="en-US" sz="1300" dirty="0"/>
+          </a:p>
+          <a:p>
+            <a:pPr marL="342900" indent="-342900">
+              <a:lnSpc>
+                <a:spcPct val="116000"/>
+              </a:lnSpc>
+              <a:buSzPct val="100000"/>
+              <a:buChar char="•"/>
+            </a:pPr>
+            <a:r>
+              <a:rPr lang="en-US" sz="1300" dirty="0">
+                <a:solidFill>
+                  <a:srgbClr val="2D3748"/>
+                </a:solidFill>
+                <a:latin typeface="Arial" pitchFamily="34" charset="0"/>
+                <a:ea typeface="Arial" pitchFamily="34" charset="-122"/>
+                <a:cs typeface="Arial" pitchFamily="34" charset="-120"/>
+              </a:rPr>
+              <a:t>Evaluation harness KPI dashboard widgets in Real-Time Testing Dashboard.</a:t>
+            </a:r>
+            <a:endParaRPr lang="en-US" sz="1300" dirty="0"/>
+          </a:p>
+        </p:txBody>
+      </p:sp>
+      <p:sp>
+        <p:nvSpPr>
+          <p:cNvPr id="5" name="Shape 3"/>
+          <p:cNvSpPr/>
+          <p:nvPr/>
+        </p:nvSpPr>
+        <p:spPr>
+          <a:xfrm>
+            <a:off x="640080" y="4663440"/>
+            <a:ext cx="10972800" cy="713232"/>
+          </a:xfrm>
+          <a:prstGeom prst="roundRect">
+            <a:avLst/>
+          </a:prstGeom>
+          <a:solidFill>
+            <a:srgbClr val="F7FAFC"/>
+          </a:solidFill>
+          <a:ln w="12700">
+            <a:solidFill>
+              <a:srgbClr val="D9E2EC"/>
+            </a:solidFill>
+            <a:prstDash val="solid"/>
+          </a:ln>
+        </p:spPr>
+      </p:sp>
+      <p:sp>
+        <p:nvSpPr>
+          <p:cNvPr id="6" name="Text 4"/>
+          <p:cNvSpPr/>
+          <p:nvPr/>
+        </p:nvSpPr>
+        <p:spPr>
+          <a:xfrm>
+            <a:off x="868680" y="4828032"/>
+            <a:ext cx="10515600" cy="384048"/>
+          </a:xfrm>
+          <a:prstGeom prst="rect">
+            <a:avLst/>
+          </a:prstGeom>
+          <a:noFill/>
+          <a:ln/>
+        </p:spPr>
+        <p:txBody>
+          <a:bodyPr wrap="square" rtlCol="0" anchor="ctr"/>
+          <a:lstStyle/>
+          <a:p>
+            <a:pPr algn="ctr" indent="0" marL="0">
+              <a:buNone/>
+            </a:pPr>
+            <a:r>
+              <a:rPr lang="en-US" sz="1000" b="1" dirty="0">
+                <a:solidFill>
+                  <a:srgbClr val="718096"/>
+                </a:solidFill>
+                <a:latin typeface="Arial" pitchFamily="34" charset="0"/>
+                <a:ea typeface="Arial" pitchFamily="34" charset="-122"/>
+                <a:cs typeface="Arial" pitchFamily="34" charset="-120"/>
+              </a:rPr>
+              <a:t>Phases 8–11 complete — see docs/How-To-Use-Agentic-Healing.md</a:t>
+            </a:r>
+            <a:endParaRPr lang="en-US" sz="1000" dirty="0"/>
+          </a:p>
+        </p:txBody>
+      </p:sp>
+    </p:spTree>
+  </p:cSld>
+  <p:clrMapOvr>
+    <a:masterClrMapping/>
+  </p:clrMapOvr>
+</p:sld>
+</file>
+
+<file path=ppt/slides/slide24.xml><?xml version="1.0" encoding="utf-8"?>
+<p:sld xmlns:a="http://schemas.openxmlformats.org/drawingml/2006/main" xmlns:r="http://schemas.openxmlformats.org/officeDocument/2006/relationships" xmlns:p="http://schemas.openxmlformats.org/presentationml/2006/main">
+  <p:cSld name="Slide 24">
     <p:bg>
       <p:bgPr>
         <a:solidFill>

</xml_diff>